<commit_message>
feat: slide 4 matrix PNG, needs list, title fix; slide 2 per-paragraph body; Safari roundRect polyfill; dataCenters in viewer
</commit_message>
<xml_diff>
--- a/source/public/P11slide.pptx
+++ b/source/public/P11slide.pptx
@@ -2757,8 +2757,8 @@
         </p:nvSpPr>
         <p:spPr>
           <a:xfrm>
-            <a:off x="1744403" y="2085974"/>
-            <a:ext cx="2333625" cy="238125"/>
+            <a:off x="487680" y="1200150"/>
+            <a:ext cx="3413760" cy="308610"/>
           </a:xfrm>
           <a:prstGeom prst="rect">
             <a:avLst/>
@@ -2952,8 +2952,8 @@
         </p:nvSpPr>
         <p:spPr>
           <a:xfrm>
-            <a:off x="1657350" y="2400300"/>
-            <a:ext cx="2333625" cy="647700"/>
+            <a:off x="487680" y="1508760"/>
+            <a:ext cx="3413760" cy="1440180"/>
           </a:xfrm>
           <a:prstGeom prst="rect">
             <a:avLst/>
@@ -3021,8 +3021,8 @@
         </p:nvSpPr>
         <p:spPr>
           <a:xfrm>
-            <a:off x="5362575" y="2076450"/>
-            <a:ext cx="2333625" cy="238125"/>
+            <a:off x="4450080" y="1200150"/>
+            <a:ext cx="3413760" cy="308610"/>
           </a:xfrm>
           <a:prstGeom prst="rect">
             <a:avLst/>
@@ -3184,8 +3184,8 @@
         </p:nvSpPr>
         <p:spPr>
           <a:xfrm>
-            <a:off x="5362575" y="2400300"/>
-            <a:ext cx="2333625" cy="647700"/>
+            <a:off x="4450080" y="1508760"/>
+            <a:ext cx="3413760" cy="1440180"/>
           </a:xfrm>
           <a:prstGeom prst="rect">
             <a:avLst/>
@@ -3253,8 +3253,8 @@
         </p:nvSpPr>
         <p:spPr>
           <a:xfrm>
-            <a:off x="9067800" y="2076450"/>
-            <a:ext cx="2333625" cy="238125"/>
+            <a:off x="8412480" y="1200150"/>
+            <a:ext cx="3413760" cy="308610"/>
           </a:xfrm>
           <a:prstGeom prst="rect">
             <a:avLst/>
@@ -3438,8 +3438,8 @@
         </p:nvSpPr>
         <p:spPr>
           <a:xfrm>
-            <a:off x="9067800" y="2400300"/>
-            <a:ext cx="2333625" cy="647700"/>
+            <a:off x="8412480" y="1508760"/>
+            <a:ext cx="3413760" cy="1440180"/>
           </a:xfrm>
           <a:prstGeom prst="rect">
             <a:avLst/>
@@ -3507,8 +3507,8 @@
         </p:nvSpPr>
         <p:spPr>
           <a:xfrm>
-            <a:off x="1657350" y="3600450"/>
-            <a:ext cx="2333625" cy="238125"/>
+            <a:off x="487680" y="3086100"/>
+            <a:ext cx="3413760" cy="308610"/>
           </a:xfrm>
           <a:prstGeom prst="rect">
             <a:avLst/>
@@ -3704,8 +3704,8 @@
         </p:nvSpPr>
         <p:spPr>
           <a:xfrm>
-            <a:off x="1657350" y="3924300"/>
-            <a:ext cx="2333625" cy="647700"/>
+            <a:off x="487680" y="3394710"/>
+            <a:ext cx="3413760" cy="1440180"/>
           </a:xfrm>
           <a:prstGeom prst="rect">
             <a:avLst/>
@@ -3755,7 +3755,7 @@
                 <a:latin typeface="Calibri"/>
                 <a:cs typeface="Calibri"/>
               </a:rPr>
-              <a:t>(Nota)</a:t>
+              <a:t>(nota_efficiency)</a:t>
             </a:r>
             <a:endParaRPr kumimoji="0" sz="900" b="0" i="0" u="none" strike="noStrike" kern="1200" cap="none" spc="0" normalizeH="0" baseline="0" noProof="0" dirty="0">
               <a:ln>
@@ -3789,8 +3789,8 @@
         </p:nvSpPr>
         <p:spPr>
           <a:xfrm>
-            <a:off x="5362575" y="3600450"/>
-            <a:ext cx="2333625" cy="238125"/>
+            <a:off x="4450080" y="3086100"/>
+            <a:ext cx="3413760" cy="308610"/>
           </a:xfrm>
           <a:prstGeom prst="rect">
             <a:avLst/>
@@ -3925,8 +3925,8 @@
         </p:nvSpPr>
         <p:spPr>
           <a:xfrm>
-            <a:off x="5362575" y="3924300"/>
-            <a:ext cx="2333625" cy="647700"/>
+            <a:off x="4450080" y="3394710"/>
+            <a:ext cx="3413760" cy="1440180"/>
           </a:xfrm>
           <a:prstGeom prst="rect">
             <a:avLst/>
@@ -3970,7 +3970,7 @@
                 <a:latin typeface="Calibri"/>
                 <a:cs typeface="Calibri"/>
               </a:rPr>
-              <a:t>(nota)</a:t>
+              <a:t>(nota_supply)</a:t>
             </a:r>
             <a:endParaRPr kumimoji="0" sz="900" b="0" i="0" u="none" strike="noStrike" kern="1200" cap="none" spc="0" normalizeH="0" baseline="0" noProof="0" dirty="0">
               <a:ln>
@@ -4004,8 +4004,8 @@
         </p:nvSpPr>
         <p:spPr>
           <a:xfrm>
-            <a:off x="9067800" y="3600450"/>
-            <a:ext cx="2564218" cy="209551"/>
+            <a:off x="8412480" y="3086100"/>
+            <a:ext cx="3413760" cy="308610"/>
           </a:xfrm>
           <a:prstGeom prst="rect">
             <a:avLst/>
@@ -4201,8 +4201,8 @@
         </p:nvSpPr>
         <p:spPr>
           <a:xfrm>
-            <a:off x="9067800" y="3924300"/>
-            <a:ext cx="2333625" cy="647700"/>
+            <a:off x="8412480" y="3394710"/>
+            <a:ext cx="3413760" cy="1440180"/>
           </a:xfrm>
           <a:prstGeom prst="rect">
             <a:avLst/>
@@ -4342,8 +4342,8 @@
         </p:nvSpPr>
         <p:spPr>
           <a:xfrm>
-            <a:off x="9111327" y="3924300"/>
-            <a:ext cx="2333625" cy="647700"/>
+            <a:off x="8412480" y="3394710"/>
+            <a:ext cx="3413760" cy="1440180"/>
           </a:xfrm>
           <a:prstGeom prst="rect">
             <a:avLst/>
@@ -4387,7 +4387,7 @@
                 <a:latin typeface="Calibri"/>
                 <a:cs typeface="Calibri"/>
               </a:rPr>
-              <a:t>(nota)</a:t>
+              <a:t>(nota_reputation)</a:t>
             </a:r>
             <a:endParaRPr kumimoji="0" sz="900" b="0" i="0" u="none" strike="noStrike" kern="1200" cap="none" spc="0" normalizeH="0" baseline="0" noProof="0" dirty="0">
               <a:ln>
@@ -4464,8 +4464,8 @@
         </p:nvSpPr>
         <p:spPr>
           <a:xfrm>
-            <a:off x="9111327" y="2352675"/>
-            <a:ext cx="2333625" cy="647700"/>
+            <a:off x="8412480" y="1508760"/>
+            <a:ext cx="3413760" cy="1440180"/>
           </a:xfrm>
           <a:prstGeom prst="rect">
             <a:avLst/>
@@ -4509,7 +4509,7 @@
                 <a:latin typeface="Calibri"/>
                 <a:cs typeface="Calibri"/>
               </a:rPr>
-              <a:t>(nota)</a:t>
+              <a:t>(nota_credit)</a:t>
             </a:r>
             <a:endParaRPr kumimoji="0" sz="900" b="0" i="0" u="none" strike="noStrike" kern="1200" cap="none" spc="0" normalizeH="0" baseline="0" noProof="0" dirty="0">
               <a:ln>
@@ -4543,8 +4543,8 @@
         </p:nvSpPr>
         <p:spPr>
           <a:xfrm>
-            <a:off x="5406102" y="2351617"/>
-            <a:ext cx="2333625" cy="647700"/>
+            <a:off x="4450080" y="1508760"/>
+            <a:ext cx="3413760" cy="1440180"/>
           </a:xfrm>
           <a:prstGeom prst="rect">
             <a:avLst/>
@@ -4588,7 +4588,7 @@
                 <a:latin typeface="Calibri"/>
                 <a:cs typeface="Calibri"/>
               </a:rPr>
-              <a:t>(nota)</a:t>
+              <a:t>(nota_compliance)</a:t>
             </a:r>
             <a:endParaRPr kumimoji="0" sz="900" b="0" i="0" u="none" strike="noStrike" kern="1200" cap="none" spc="0" normalizeH="0" baseline="0" noProof="0" dirty="0">
               <a:ln>
@@ -4622,8 +4622,8 @@
         </p:nvSpPr>
         <p:spPr>
           <a:xfrm>
-            <a:off x="1744404" y="2369412"/>
-            <a:ext cx="2333625" cy="647700"/>
+            <a:off x="487680" y="1508760"/>
+            <a:ext cx="3413760" cy="1440180"/>
           </a:xfrm>
           <a:prstGeom prst="rect">
             <a:avLst/>
@@ -4667,7 +4667,7 @@
                 <a:latin typeface="Calibri"/>
                 <a:cs typeface="Calibri"/>
               </a:rPr>
-              <a:t>(nota)</a:t>
+              <a:t>(nota_customers)</a:t>
             </a:r>
             <a:endParaRPr kumimoji="0" sz="900" b="0" i="0" u="none" strike="noStrike" kern="1200" cap="none" spc="0" normalizeH="0" baseline="0" noProof="0" dirty="0">
               <a:ln>

</xml_diff>